<commit_message>
clean up reports, produce manuscript figure
</commit_message>
<xml_diff>
--- a/Manuscripts/ReportFigs/ScatterDemo.pptx
+++ b/Manuscripts/ReportFigs/ScatterDemo.pptx
@@ -130,7 +130,7 @@
   <pc:docChgLst>
     <pc:chgData name="Jin, Ying (NIH/NIEHS) [F]" userId="f3351207-9ce7-4a29-ab74-5fe270738334" providerId="ADAL" clId="{DC1D6C2D-6C94-58FE-945A-9CFD37BD2A7E}"/>
     <pc:docChg chg="undo custSel addSld modSld">
-      <pc:chgData name="Jin, Ying (NIH/NIEHS) [F]" userId="f3351207-9ce7-4a29-ab74-5fe270738334" providerId="ADAL" clId="{DC1D6C2D-6C94-58FE-945A-9CFD37BD2A7E}" dt="2026-02-19T21:34:08.566" v="134" actId="1076"/>
+      <pc:chgData name="Jin, Ying (NIH/NIEHS) [F]" userId="f3351207-9ce7-4a29-ab74-5fe270738334" providerId="ADAL" clId="{DC1D6C2D-6C94-58FE-945A-9CFD37BD2A7E}" dt="2026-02-26T18:08:01.335" v="136" actId="14100"/>
       <pc:docMkLst>
         <pc:docMk/>
       </pc:docMkLst>
@@ -150,53 +150,21 @@
         </pc:spChg>
       </pc:sldChg>
       <pc:sldChg chg="addSp delSp modSp new mod modNotesTx">
-        <pc:chgData name="Jin, Ying (NIH/NIEHS) [F]" userId="f3351207-9ce7-4a29-ab74-5fe270738334" providerId="ADAL" clId="{DC1D6C2D-6C94-58FE-945A-9CFD37BD2A7E}" dt="2026-02-19T21:17:02.169" v="118" actId="1076"/>
+        <pc:chgData name="Jin, Ying (NIH/NIEHS) [F]" userId="f3351207-9ce7-4a29-ab74-5fe270738334" providerId="ADAL" clId="{DC1D6C2D-6C94-58FE-945A-9CFD37BD2A7E}" dt="2026-02-26T18:08:01.335" v="136" actId="14100"/>
         <pc:sldMkLst>
           <pc:docMk/>
           <pc:sldMk cId="1535606021" sldId="257"/>
         </pc:sldMkLst>
         <pc:spChg chg="mod">
-          <ac:chgData name="Jin, Ying (NIH/NIEHS) [F]" userId="f3351207-9ce7-4a29-ab74-5fe270738334" providerId="ADAL" clId="{DC1D6C2D-6C94-58FE-945A-9CFD37BD2A7E}" dt="2026-02-19T21:10:41.414" v="12" actId="404"/>
+          <ac:chgData name="Jin, Ying (NIH/NIEHS) [F]" userId="f3351207-9ce7-4a29-ab74-5fe270738334" providerId="ADAL" clId="{DC1D6C2D-6C94-58FE-945A-9CFD37BD2A7E}" dt="2026-02-26T18:07:40.727" v="135" actId="1076"/>
           <ac:spMkLst>
             <pc:docMk/>
             <pc:sldMk cId="1535606021" sldId="257"/>
             <ac:spMk id="2" creationId="{D0D2BB98-D3AE-9E47-494B-889FB8F0D5AE}"/>
           </ac:spMkLst>
         </pc:spChg>
-        <pc:spChg chg="add del">
-          <ac:chgData name="Jin, Ying (NIH/NIEHS) [F]" userId="f3351207-9ce7-4a29-ab74-5fe270738334" providerId="ADAL" clId="{DC1D6C2D-6C94-58FE-945A-9CFD37BD2A7E}" dt="2026-02-19T21:16:45.697" v="108"/>
-          <ac:spMkLst>
-            <pc:docMk/>
-            <pc:sldMk cId="1535606021" sldId="257"/>
-            <ac:spMk id="3" creationId="{5CEF848E-3676-78DB-D8C8-FD7D510CBE95}"/>
-          </ac:spMkLst>
-        </pc:spChg>
-        <pc:spChg chg="add del mod">
-          <ac:chgData name="Jin, Ying (NIH/NIEHS) [F]" userId="f3351207-9ce7-4a29-ab74-5fe270738334" providerId="ADAL" clId="{DC1D6C2D-6C94-58FE-945A-9CFD37BD2A7E}" dt="2026-02-19T21:16:36.524" v="99" actId="478"/>
-          <ac:spMkLst>
-            <pc:docMk/>
-            <pc:sldMk cId="1535606021" sldId="257"/>
-            <ac:spMk id="9" creationId="{9B6E80E9-DEF0-F608-DF51-CEF395DE87FE}"/>
-          </ac:spMkLst>
-        </pc:spChg>
-        <pc:picChg chg="add del mod ord">
-          <ac:chgData name="Jin, Ying (NIH/NIEHS) [F]" userId="f3351207-9ce7-4a29-ab74-5fe270738334" providerId="ADAL" clId="{DC1D6C2D-6C94-58FE-945A-9CFD37BD2A7E}" dt="2026-02-19T21:16:39.988" v="106" actId="931"/>
-          <ac:picMkLst>
-            <pc:docMk/>
-            <pc:sldMk cId="1535606021" sldId="257"/>
-            <ac:picMk id="5" creationId="{D8979869-358E-5124-9C47-DD383963FC65}"/>
-          </ac:picMkLst>
-        </pc:picChg>
-        <pc:picChg chg="add del mod">
-          <ac:chgData name="Jin, Ying (NIH/NIEHS) [F]" userId="f3351207-9ce7-4a29-ab74-5fe270738334" providerId="ADAL" clId="{DC1D6C2D-6C94-58FE-945A-9CFD37BD2A7E}" dt="2026-02-19T21:16:38.548" v="103" actId="931"/>
-          <ac:picMkLst>
-            <pc:docMk/>
-            <pc:sldMk cId="1535606021" sldId="257"/>
-            <ac:picMk id="7" creationId="{C608AC78-9C19-F8B3-86DF-583031301A7A}"/>
-          </ac:picMkLst>
-        </pc:picChg>
         <pc:picChg chg="add mod ord">
-          <ac:chgData name="Jin, Ying (NIH/NIEHS) [F]" userId="f3351207-9ce7-4a29-ab74-5fe270738334" providerId="ADAL" clId="{DC1D6C2D-6C94-58FE-945A-9CFD37BD2A7E}" dt="2026-02-19T21:17:00.459" v="117" actId="1076"/>
+          <ac:chgData name="Jin, Ying (NIH/NIEHS) [F]" userId="f3351207-9ce7-4a29-ab74-5fe270738334" providerId="ADAL" clId="{DC1D6C2D-6C94-58FE-945A-9CFD37BD2A7E}" dt="2026-02-26T18:08:01.335" v="136" actId="14100"/>
           <ac:picMkLst>
             <pc:docMk/>
             <pc:sldMk cId="1535606021" sldId="257"/>
@@ -204,7 +172,7 @@
           </ac:picMkLst>
         </pc:picChg>
         <pc:picChg chg="add mod">
-          <ac:chgData name="Jin, Ying (NIH/NIEHS) [F]" userId="f3351207-9ce7-4a29-ab74-5fe270738334" providerId="ADAL" clId="{DC1D6C2D-6C94-58FE-945A-9CFD37BD2A7E}" dt="2026-02-19T21:17:02.169" v="118" actId="1076"/>
+          <ac:chgData name="Jin, Ying (NIH/NIEHS) [F]" userId="f3351207-9ce7-4a29-ab74-5fe270738334" providerId="ADAL" clId="{DC1D6C2D-6C94-58FE-945A-9CFD37BD2A7E}" dt="2026-02-26T18:08:01.335" v="136" actId="14100"/>
           <ac:picMkLst>
             <pc:docMk/>
             <pc:sldMk cId="1535606021" sldId="257"/>
@@ -224,14 +192,6 @@
             <pc:docMk/>
             <pc:sldMk cId="1842047305" sldId="258"/>
             <ac:spMk id="2" creationId="{40ECB511-7B2A-CAEA-D39F-8AF7C3E2AD39}"/>
-          </ac:spMkLst>
-        </pc:spChg>
-        <pc:spChg chg="del">
-          <ac:chgData name="Jin, Ying (NIH/NIEHS) [F]" userId="f3351207-9ce7-4a29-ab74-5fe270738334" providerId="ADAL" clId="{DC1D6C2D-6C94-58FE-945A-9CFD37BD2A7E}" dt="2026-02-19T21:33:52.874" v="127"/>
-          <ac:spMkLst>
-            <pc:docMk/>
-            <pc:sldMk cId="1842047305" sldId="258"/>
-            <ac:spMk id="3" creationId="{59318620-D623-79EA-ED50-643117D8A029}"/>
           </ac:spMkLst>
         </pc:spChg>
         <pc:picChg chg="add mod ord">
@@ -338,7 +298,7 @@
           <a:p>
             <a:fld id="{09F01B83-CDD8-594D-A3FB-0682CA8D5D91}" type="datetimeFigureOut">
               <a:rPr lang="en-US" smtClean="0"/>
-              <a:t>2/19/26</a:t>
+              <a:t>2/26/26</a:t>
             </a:fld>
             <a:endParaRPr lang="en-US"/>
           </a:p>
@@ -904,7 +864,7 @@
           <a:p>
             <a:fld id="{761692B0-3AB8-2F45-A6EC-C118D69994F7}" type="datetimeFigureOut">
               <a:rPr lang="en-US" smtClean="0"/>
-              <a:t>2/19/26</a:t>
+              <a:t>2/26/26</a:t>
             </a:fld>
             <a:endParaRPr lang="en-US"/>
           </a:p>
@@ -1074,7 +1034,7 @@
           <a:p>
             <a:fld id="{761692B0-3AB8-2F45-A6EC-C118D69994F7}" type="datetimeFigureOut">
               <a:rPr lang="en-US" smtClean="0"/>
-              <a:t>2/19/26</a:t>
+              <a:t>2/26/26</a:t>
             </a:fld>
             <a:endParaRPr lang="en-US"/>
           </a:p>
@@ -1254,7 +1214,7 @@
           <a:p>
             <a:fld id="{761692B0-3AB8-2F45-A6EC-C118D69994F7}" type="datetimeFigureOut">
               <a:rPr lang="en-US" smtClean="0"/>
-              <a:t>2/19/26</a:t>
+              <a:t>2/26/26</a:t>
             </a:fld>
             <a:endParaRPr lang="en-US"/>
           </a:p>
@@ -1424,7 +1384,7 @@
           <a:p>
             <a:fld id="{761692B0-3AB8-2F45-A6EC-C118D69994F7}" type="datetimeFigureOut">
               <a:rPr lang="en-US" smtClean="0"/>
-              <a:t>2/19/26</a:t>
+              <a:t>2/26/26</a:t>
             </a:fld>
             <a:endParaRPr lang="en-US"/>
           </a:p>
@@ -1670,7 +1630,7 @@
           <a:p>
             <a:fld id="{761692B0-3AB8-2F45-A6EC-C118D69994F7}" type="datetimeFigureOut">
               <a:rPr lang="en-US" smtClean="0"/>
-              <a:t>2/19/26</a:t>
+              <a:t>2/26/26</a:t>
             </a:fld>
             <a:endParaRPr lang="en-US"/>
           </a:p>
@@ -1902,7 +1862,7 @@
           <a:p>
             <a:fld id="{761692B0-3AB8-2F45-A6EC-C118D69994F7}" type="datetimeFigureOut">
               <a:rPr lang="en-US" smtClean="0"/>
-              <a:t>2/19/26</a:t>
+              <a:t>2/26/26</a:t>
             </a:fld>
             <a:endParaRPr lang="en-US"/>
           </a:p>
@@ -2269,7 +2229,7 @@
           <a:p>
             <a:fld id="{761692B0-3AB8-2F45-A6EC-C118D69994F7}" type="datetimeFigureOut">
               <a:rPr lang="en-US" smtClean="0"/>
-              <a:t>2/19/26</a:t>
+              <a:t>2/26/26</a:t>
             </a:fld>
             <a:endParaRPr lang="en-US"/>
           </a:p>
@@ -2387,7 +2347,7 @@
           <a:p>
             <a:fld id="{761692B0-3AB8-2F45-A6EC-C118D69994F7}" type="datetimeFigureOut">
               <a:rPr lang="en-US" smtClean="0"/>
-              <a:t>2/19/26</a:t>
+              <a:t>2/26/26</a:t>
             </a:fld>
             <a:endParaRPr lang="en-US"/>
           </a:p>
@@ -2482,7 +2442,7 @@
           <a:p>
             <a:fld id="{761692B0-3AB8-2F45-A6EC-C118D69994F7}" type="datetimeFigureOut">
               <a:rPr lang="en-US" smtClean="0"/>
-              <a:t>2/19/26</a:t>
+              <a:t>2/26/26</a:t>
             </a:fld>
             <a:endParaRPr lang="en-US"/>
           </a:p>
@@ -2759,7 +2719,7 @@
           <a:p>
             <a:fld id="{761692B0-3AB8-2F45-A6EC-C118D69994F7}" type="datetimeFigureOut">
               <a:rPr lang="en-US" smtClean="0"/>
-              <a:t>2/19/26</a:t>
+              <a:t>2/26/26</a:t>
             </a:fld>
             <a:endParaRPr lang="en-US"/>
           </a:p>
@@ -3016,7 +2976,7 @@
           <a:p>
             <a:fld id="{761692B0-3AB8-2F45-A6EC-C118D69994F7}" type="datetimeFigureOut">
               <a:rPr lang="en-US" smtClean="0"/>
-              <a:t>2/19/26</a:t>
+              <a:t>2/26/26</a:t>
             </a:fld>
             <a:endParaRPr lang="en-US"/>
           </a:p>
@@ -3229,7 +3189,7 @@
           <a:p>
             <a:fld id="{761692B0-3AB8-2F45-A6EC-C118D69994F7}" type="datetimeFigureOut">
               <a:rPr lang="en-US" smtClean="0"/>
-              <a:t>2/19/26</a:t>
+              <a:t>2/26/26</a:t>
             </a:fld>
             <a:endParaRPr lang="en-US"/>
           </a:p>
@@ -3777,7 +3737,7 @@
         </p:nvSpPr>
         <p:spPr>
           <a:xfrm>
-            <a:off x="471488" y="488441"/>
+            <a:off x="618026" y="406969"/>
             <a:ext cx="5915025" cy="611697"/>
           </a:xfrm>
         </p:spPr>

</xml_diff>